<commit_message>
feat: template.pptx에 Pretendard 포함 (보통·굵게, 모든 문자)
- 노트 테마에 남아 있던 함초롬돋움을 Pretendard로 교체
- 발표 PC에 Pretendard가 없어도 PowerPoint에서 서체가 유지됨

Co-Authored-By: Claude Opus 5.5 <noreply@anthropic.com>
</commit_message>
<xml_diff>
--- a/template.pptx
+++ b/template.pptx
@@ -1,6 +1,6 @@
 
 <file path=ppt/presentation.xml><?xml version="1.0" encoding="utf-8"?>
-<p:presentation xmlns:a="http://schemas.openxmlformats.org/drawingml/2006/main" xmlns:r="http://schemas.openxmlformats.org/officeDocument/2006/relationships" xmlns:p="http://schemas.openxmlformats.org/presentationml/2006/main" saveSubsetFonts="1">
+<p:presentation xmlns:a="http://schemas.openxmlformats.org/drawingml/2006/main" xmlns:r="http://schemas.openxmlformats.org/officeDocument/2006/relationships" xmlns:p="http://schemas.openxmlformats.org/presentationml/2006/main" embedTrueTypeFonts="1">
   <p:sldMasterIdLst>
     <p:sldMasterId id="2147483660" r:id="rId1"/>
   </p:sldMasterIdLst>
@@ -12,6 +12,13 @@
   </p:sldIdLst>
   <p:sldSz cx="9144000" cy="5143500" type="screen16x9"/>
   <p:notesSz cx="6858000" cy="9144000"/>
+  <p:embeddedFontLst>
+    <p:embeddedFont>
+      <p:font typeface="Pretendard" panose="02000503000000020004" pitchFamily="2" charset="-127"/>
+      <p:regular r:id="rId4"/>
+      <p:bold r:id="rId5"/>
+    </p:embeddedFont>
+  </p:embeddedFontLst>
   <p:defaultTextStyle>
     <a:defPPr>
       <a:defRPr lang="ko-KR"/>
@@ -217,7 +224,7 @@
               <a:pPr lvl="0">
                 <a:defRPr lang="ko-KR" altLang="en-US"/>
               </a:pPr>
-              <a:t>2025. 5. 10.</a:t>
+              <a:t>2026. 10. 12.</a:t>
             </a:fld>
             <a:endParaRPr lang="ko-KR" altLang="en-US"/>
           </a:p>
@@ -684,7 +691,7 @@
             <a:fld id="{CCC3D61B-4551-4FD2-AA00-C6D5670339EB}" type="datetimeFigureOut">
               <a:rPr lang="ko-KR" altLang="en-US" smtClean="0"/>
               <a:pPr/>
-              <a:t>2025. 5. 10.</a:t>
+              <a:t>2026. 10. 12.</a:t>
             </a:fld>
             <a:endParaRPr lang="ko-KR" altLang="en-US"/>
           </a:p>
@@ -867,7 +874,7 @@
               <a:pPr lvl="0">
                 <a:defRPr lang="ko-KR" altLang="en-US"/>
               </a:pPr>
-              <a:t>2025. 5. 10.</a:t>
+              <a:t>2026. 10. 12.</a:t>
             </a:fld>
             <a:endParaRPr lang="ko-KR" altLang="en-US"/>
           </a:p>
@@ -1069,7 +1076,7 @@
               <a:pPr lvl="0">
                 <a:defRPr lang="ko-KR" altLang="en-US"/>
               </a:pPr>
-              <a:t>2025. 5. 10.</a:t>
+              <a:t>2026. 10. 12.</a:t>
             </a:fld>
             <a:endParaRPr lang="ko-KR" altLang="en-US"/>
           </a:p>
@@ -1261,7 +1268,7 @@
               <a:pPr lvl="0">
                 <a:defRPr lang="ko-KR" altLang="en-US"/>
               </a:pPr>
-              <a:t>2025. 5. 10.</a:t>
+              <a:t>2026. 10. 12.</a:t>
             </a:fld>
             <a:endParaRPr lang="ko-KR" altLang="en-US"/>
           </a:p>
@@ -1522,7 +1529,7 @@
               <a:pPr lvl="0">
                 <a:defRPr lang="ko-KR" altLang="en-US"/>
               </a:pPr>
-              <a:t>2025. 5. 10.</a:t>
+              <a:t>2026. 10. 12.</a:t>
             </a:fld>
             <a:endParaRPr lang="ko-KR" altLang="en-US"/>
           </a:p>
@@ -1841,7 +1848,7 @@
               <a:pPr lvl="0">
                 <a:defRPr lang="ko-KR" altLang="en-US"/>
               </a:pPr>
-              <a:t>2025. 5. 10.</a:t>
+              <a:t>2026. 10. 12.</a:t>
             </a:fld>
             <a:endParaRPr lang="ko-KR" altLang="en-US"/>
           </a:p>
@@ -2303,7 +2310,7 @@
               <a:pPr lvl="0">
                 <a:defRPr lang="ko-KR" altLang="en-US"/>
               </a:pPr>
-              <a:t>2025. 5. 10.</a:t>
+              <a:t>2026. 10. 12.</a:t>
             </a:fld>
             <a:endParaRPr lang="ko-KR" altLang="en-US"/>
           </a:p>
@@ -2434,7 +2441,7 @@
               <a:pPr lvl="0">
                 <a:defRPr lang="ko-KR" altLang="en-US"/>
               </a:pPr>
-              <a:t>2025. 5. 10.</a:t>
+              <a:t>2026. 10. 12.</a:t>
             </a:fld>
             <a:endParaRPr lang="ko-KR" altLang="en-US"/>
           </a:p>
@@ -2540,7 +2547,7 @@
               <a:pPr lvl="0">
                 <a:defRPr lang="ko-KR" altLang="en-US"/>
               </a:pPr>
-              <a:t>2025. 5. 10.</a:t>
+              <a:t>2026. 10. 12.</a:t>
             </a:fld>
             <a:endParaRPr lang="ko-KR" altLang="en-US"/>
           </a:p>
@@ -2841,7 +2848,7 @@
               <a:pPr lvl="0">
                 <a:defRPr lang="ko-KR" altLang="en-US"/>
               </a:pPr>
-              <a:t>2025. 5. 10.</a:t>
+              <a:t>2026. 10. 12.</a:t>
             </a:fld>
             <a:endParaRPr lang="ko-KR" altLang="en-US"/>
           </a:p>
@@ -3112,7 +3119,7 @@
               <a:pPr lvl="0">
                 <a:defRPr lang="ko-KR" altLang="en-US"/>
               </a:pPr>
-              <a:t>2025. 5. 10.</a:t>
+              <a:t>2026. 10. 12.</a:t>
             </a:fld>
             <a:endParaRPr lang="ko-KR" altLang="en-US"/>
           </a:p>
@@ -3329,7 +3336,7 @@
             <a:fld id="{CCC3D61B-4551-4FD2-AA00-C6D5670339EB}" type="datetimeFigureOut">
               <a:rPr lang="ko-KR" altLang="en-US" smtClean="0"/>
               <a:pPr/>
-              <a:t>2025. 5. 10.</a:t>
+              <a:t>2026. 10. 12.</a:t>
             </a:fld>
             <a:endParaRPr lang="ko-KR" altLang="en-US"/>
           </a:p>
@@ -3772,7 +3779,7 @@
     <mc:Choice Requires="p14">
       <p:transition/>
     </mc:Choice>
-    <mc:Fallback xmlns="" xmlns:c="http://schemas.openxmlformats.org/drawingml/2006/chart" xmlns:dgm="http://schemas.openxmlformats.org/drawingml/2006/diagram" xmlns:dsp="http://schemas.microsoft.com/office/drawing/2008/diagram">
+    <mc:Fallback xmlns:dsp="http://schemas.microsoft.com/office/drawing/2008/diagram" xmlns:dgm="http://schemas.openxmlformats.org/drawingml/2006/diagram" xmlns:c="http://schemas.openxmlformats.org/drawingml/2006/chart" xmlns="">
       <p:transition/>
     </mc:Fallback>
   </mc:AlternateContent>
@@ -4105,14 +4112,14 @@
     </a:clrScheme>
     <a:fontScheme name="한컴오피스">
       <a:majorFont>
-        <a:latin typeface="함초롬돋움"/>
-        <a:ea typeface="함초롬돋움"/>
-        <a:cs typeface="함초롬돋움"/>
+        <a:latin typeface="Pretendard"/>
+        <a:ea typeface="Pretendard"/>
+        <a:cs typeface="Pretendard"/>
       </a:majorFont>
       <a:minorFont>
-        <a:latin typeface="함초롬돋움"/>
-        <a:ea typeface="함초롬돋움"/>
-        <a:cs typeface="함초롬돋움"/>
+        <a:latin typeface="Pretendard"/>
+        <a:ea typeface="Pretendard"/>
+        <a:cs typeface="Pretendard"/>
       </a:minorFont>
     </a:fontScheme>
     <a:fmtScheme name="한컴오피스">

</xml_diff>